<commit_message>
Package current monitoring and deployment enhancements with updated briefing
</commit_message>
<xml_diff>
--- a/VulnSuite_Executive_Deck.pptx
+++ b/VulnSuite_Executive_Deck.pptx
@@ -24,6 +24,7 @@
     <p:sldId id="272" r:id="rId24"/>
     <p:sldId id="273" r:id="rId25"/>
     <p:sldId id="274" r:id="rId26"/>
+    <p:sldId id="275" r:id="rId27"/>
   </p:sldIdLst>
   <p:sldSz cx="12191695" cy="6858000" type="screen4x3"/>
   <p:notesSz cx="6858000" cy="9144000"/>
@@ -1516,6 +1517,96 @@
           <a:p>
             <a:r>
               <a:t>Scope: Selected detection signals support investigation; coverage is not equivalent to a complete EDR platform.</a:t>
+            </a:r>
+          </a:p>
+          <a:p>
+            <a:r>
+              <a:t>Implementation and limitations: vulnsuite/protection/OPERATIONS.md</a:t>
+            </a:r>
+          </a:p>
+          <a:p>
+            <a:r>
+              <a:t>Staging and maintenance: deploy/protection/OPERATIONS.md</a:t>
+            </a:r>
+          </a:p>
+          <a:p>
+            <a:r>
+              <a:t>Automated validation does not establish live enforcement or full EDR coverage.</a:t>
+            </a:r>
+          </a:p>
+        </p:txBody>
+      </p:sp>
+      <p:sp>
+        <p:nvSpPr>
+          <p:cNvPr id="4" name="Slide Number Placeholder 3"/>
+          <p:cNvSpPr>
+            <a:spLocks noGrp="1"/>
+          </p:cNvSpPr>
+          <p:nvPr>
+            <p:ph type="sldNum" idx="5" sz="quarter"/>
+          </p:nvPr>
+        </p:nvSpPr>
+        <p:spPr/>
+      </p:sp>
+    </p:spTree>
+  </p:cSld>
+  <p:clrMapOvr>
+    <a:masterClrMapping/>
+  </p:clrMapOvr>
+</p:notes>
+</file>
+
+<file path=ppt/notesSlides/notesSlide20.xml><?xml version="1.0" encoding="utf-8"?>
+<p:notes xmlns:a="http://schemas.openxmlformats.org/drawingml/2006/main" xmlns:p="http://schemas.openxmlformats.org/presentationml/2006/main" xmlns:r="http://schemas.openxmlformats.org/officeDocument/2006/relationships">
+  <p:cSld>
+    <p:spTree>
+      <p:nvGrpSpPr>
+        <p:cNvPr id="1" name=""/>
+        <p:cNvGrpSpPr/>
+        <p:nvPr/>
+      </p:nvGrpSpPr>
+      <p:grpSpPr>
+        <a:xfrm>
+          <a:off x="0" y="0"/>
+          <a:ext cx="0" cy="0"/>
+          <a:chOff x="0" y="0"/>
+          <a:chExt cx="0" cy="0"/>
+        </a:xfrm>
+      </p:grpSpPr>
+      <p:sp>
+        <p:nvSpPr>
+          <p:cNvPr id="2" name="Slide Image Placeholder 1"/>
+          <p:cNvSpPr>
+            <a:spLocks noGrp="1"/>
+          </p:cNvSpPr>
+          <p:nvPr>
+            <p:ph type="sldImg" idx="2"/>
+          </p:nvPr>
+        </p:nvSpPr>
+        <p:spPr/>
+      </p:sp>
+      <p:sp>
+        <p:nvSpPr>
+          <p:cNvPr id="3" name="Notes Placeholder 2"/>
+          <p:cNvSpPr>
+            <a:spLocks noGrp="1"/>
+          </p:cNvSpPr>
+          <p:nvPr>
+            <p:ph type="body" idx="3" sz="quarter"/>
+          </p:nvPr>
+        </p:nvSpPr>
+        <p:spPr/>
+        <p:txBody>
+          <a:bodyPr/>
+          <a:lstStyle/>
+          <a:p>
+            <a:r>
+              <a:t>The deployment adds a continuous monitoring dashboard, bounded host collectors, local source scanning and service templates. Health checks expose stale snapshots, while tenant-scoped access connects findings to operations. Deployment details and limits are documented in vulnsuite/README.md.</a:t>
+            </a:r>
+          </a:p>
+          <a:p>
+            <a:r>
+              <a:t>Scope: Coverage depends on configured sources and targets; installed scanners do not imply active coverage.</a:t>
             </a:r>
           </a:p>
           <a:p>
@@ -5818,7 +5909,7 @@
               </a:defRPr>
             </a:pPr>
             <a:r>
-              <a:t>CONFIDENTIAL • INTERNAL REVIEW  |  19 October 2026</a:t>
+              <a:t>CONFIDENTIAL • INTERNAL REVIEW  |  21 October 2026</a:t>
             </a:r>
           </a:p>
         </p:txBody>
@@ -5857,7 +5948,7 @@
               </a:defRPr>
             </a:pPr>
             <a:r>
-              <a:t>01 / 19</a:t>
+              <a:t>01 / 20</a:t>
             </a:r>
           </a:p>
         </p:txBody>
@@ -6572,7 +6663,7 @@
               </a:defRPr>
             </a:pPr>
             <a:r>
-              <a:t>CONFIDENTIAL • INTERNAL REVIEW  |  19 October 2026</a:t>
+              <a:t>CONFIDENTIAL • INTERNAL REVIEW  |  21 October 2026</a:t>
             </a:r>
           </a:p>
         </p:txBody>
@@ -6611,7 +6702,7 @@
               </a:defRPr>
             </a:pPr>
             <a:r>
-              <a:t>10 / 19</a:t>
+              <a:t>10 / 20</a:t>
             </a:r>
           </a:p>
         </p:txBody>
@@ -7326,7 +7417,7 @@
               </a:defRPr>
             </a:pPr>
             <a:r>
-              <a:t>CONFIDENTIAL • INTERNAL REVIEW  |  19 October 2026</a:t>
+              <a:t>CONFIDENTIAL • INTERNAL REVIEW  |  21 October 2026</a:t>
             </a:r>
           </a:p>
         </p:txBody>
@@ -7365,7 +7456,7 @@
               </a:defRPr>
             </a:pPr>
             <a:r>
-              <a:t>11 / 19</a:t>
+              <a:t>11 / 20</a:t>
             </a:r>
           </a:p>
         </p:txBody>
@@ -8080,7 +8171,7 @@
               </a:defRPr>
             </a:pPr>
             <a:r>
-              <a:t>CONFIDENTIAL • INTERNAL REVIEW  |  19 October 2026</a:t>
+              <a:t>CONFIDENTIAL • INTERNAL REVIEW  |  21 October 2026</a:t>
             </a:r>
           </a:p>
         </p:txBody>
@@ -8119,7 +8210,7 @@
               </a:defRPr>
             </a:pPr>
             <a:r>
-              <a:t>12 / 19</a:t>
+              <a:t>12 / 20</a:t>
             </a:r>
           </a:p>
         </p:txBody>
@@ -8834,7 +8925,7 @@
               </a:defRPr>
             </a:pPr>
             <a:r>
-              <a:t>CONFIDENTIAL • INTERNAL REVIEW  |  19 October 2026</a:t>
+              <a:t>CONFIDENTIAL • INTERNAL REVIEW  |  21 October 2026</a:t>
             </a:r>
           </a:p>
         </p:txBody>
@@ -8873,7 +8964,7 @@
               </a:defRPr>
             </a:pPr>
             <a:r>
-              <a:t>13 / 19</a:t>
+              <a:t>13 / 20</a:t>
             </a:r>
           </a:p>
         </p:txBody>
@@ -9588,7 +9679,7 @@
               </a:defRPr>
             </a:pPr>
             <a:r>
-              <a:t>CONFIDENTIAL • INTERNAL REVIEW  |  19 October 2026</a:t>
+              <a:t>CONFIDENTIAL • INTERNAL REVIEW  |  21 October 2026</a:t>
             </a:r>
           </a:p>
         </p:txBody>
@@ -9627,7 +9718,7 @@
               </a:defRPr>
             </a:pPr>
             <a:r>
-              <a:t>14 / 19</a:t>
+              <a:t>14 / 20</a:t>
             </a:r>
           </a:p>
         </p:txBody>
@@ -10342,7 +10433,7 @@
               </a:defRPr>
             </a:pPr>
             <a:r>
-              <a:t>CONFIDENTIAL • INTERNAL REVIEW  |  19 October 2026</a:t>
+              <a:t>CONFIDENTIAL • INTERNAL REVIEW  |  21 October 2026</a:t>
             </a:r>
           </a:p>
         </p:txBody>
@@ -10381,7 +10472,7 @@
               </a:defRPr>
             </a:pPr>
             <a:r>
-              <a:t>15 / 19</a:t>
+              <a:t>15 / 20</a:t>
             </a:r>
           </a:p>
         </p:txBody>
@@ -11096,7 +11187,7 @@
               </a:defRPr>
             </a:pPr>
             <a:r>
-              <a:t>CONFIDENTIAL • INTERNAL REVIEW  |  19 October 2026</a:t>
+              <a:t>CONFIDENTIAL • INTERNAL REVIEW  |  21 October 2026</a:t>
             </a:r>
           </a:p>
         </p:txBody>
@@ -11135,7 +11226,7 @@
               </a:defRPr>
             </a:pPr>
             <a:r>
-              <a:t>16 / 19</a:t>
+              <a:t>16 / 20</a:t>
             </a:r>
           </a:p>
         </p:txBody>
@@ -11850,7 +11941,7 @@
               </a:defRPr>
             </a:pPr>
             <a:r>
-              <a:t>CONFIDENTIAL • INTERNAL REVIEW  |  19 October 2026</a:t>
+              <a:t>CONFIDENTIAL • INTERNAL REVIEW  |  21 October 2026</a:t>
             </a:r>
           </a:p>
         </p:txBody>
@@ -11889,7 +11980,7 @@
               </a:defRPr>
             </a:pPr>
             <a:r>
-              <a:t>17 / 19</a:t>
+              <a:t>17 / 20</a:t>
             </a:r>
           </a:p>
         </p:txBody>
@@ -12604,7 +12695,7 @@
               </a:defRPr>
             </a:pPr>
             <a:r>
-              <a:t>CONFIDENTIAL • INTERNAL REVIEW  |  19 October 2026</a:t>
+              <a:t>CONFIDENTIAL • INTERNAL REVIEW  |  21 October 2026</a:t>
             </a:r>
           </a:p>
         </p:txBody>
@@ -12643,7 +12734,7 @@
               </a:defRPr>
             </a:pPr>
             <a:r>
-              <a:t>18 / 19</a:t>
+              <a:t>18 / 20</a:t>
             </a:r>
           </a:p>
         </p:txBody>
@@ -13358,7 +13449,7 @@
               </a:defRPr>
             </a:pPr>
             <a:r>
-              <a:t>CONFIDENTIAL • INTERNAL REVIEW  |  19 October 2026</a:t>
+              <a:t>CONFIDENTIAL • INTERNAL REVIEW  |  21 October 2026</a:t>
             </a:r>
           </a:p>
         </p:txBody>
@@ -13397,7 +13488,7 @@
               </a:defRPr>
             </a:pPr>
             <a:r>
-              <a:t>19 / 19</a:t>
+              <a:t>19 / 20</a:t>
             </a:r>
           </a:p>
         </p:txBody>
@@ -14072,7 +14163,7 @@
               </a:defRPr>
             </a:pPr>
             <a:r>
-              <a:t>CONFIDENTIAL • INTERNAL REVIEW  |  19 October 2026</a:t>
+              <a:t>CONFIDENTIAL • INTERNAL REVIEW  |  21 October 2026</a:t>
             </a:r>
           </a:p>
         </p:txBody>
@@ -14111,7 +14202,761 @@
               </a:defRPr>
             </a:pPr>
             <a:r>
-              <a:t>02 / 19</a:t>
+              <a:t>02 / 20</a:t>
+            </a:r>
+          </a:p>
+        </p:txBody>
+      </p:sp>
+    </p:spTree>
+  </p:cSld>
+  <p:clrMapOvr>
+    <a:masterClrMapping/>
+  </p:clrMapOvr>
+</p:sld>
+</file>
+
+<file path=ppt/slides/slide20.xml><?xml version="1.0" encoding="utf-8"?>
+<p:sld xmlns:a="http://schemas.openxmlformats.org/drawingml/2006/main" xmlns:p="http://schemas.openxmlformats.org/presentationml/2006/main" xmlns:r="http://schemas.openxmlformats.org/officeDocument/2006/relationships">
+  <p:cSld>
+    <p:spTree>
+      <p:nvGrpSpPr>
+        <p:cNvPr id="1" name=""/>
+        <p:cNvGrpSpPr/>
+        <p:nvPr/>
+      </p:nvGrpSpPr>
+      <p:grpSpPr/>
+      <p:sp>
+        <p:nvSpPr>
+          <p:cNvPr id="2" name="Rectangle 1"/>
+          <p:cNvSpPr/>
+          <p:nvPr/>
+        </p:nvSpPr>
+        <p:spPr>
+          <a:xfrm>
+            <a:off x="0" y="0"/>
+            <a:ext cx="12191695" cy="91440"/>
+          </a:xfrm>
+          <a:prstGeom prst="rect">
+            <a:avLst/>
+          </a:prstGeom>
+          <a:solidFill>
+            <a:srgbClr val="F38020"/>
+          </a:solidFill>
+          <a:ln>
+            <a:noFill/>
+          </a:ln>
+        </p:spPr>
+        <p:style>
+          <a:lnRef idx="1">
+            <a:schemeClr val="accent1"/>
+          </a:lnRef>
+          <a:fillRef idx="3">
+            <a:schemeClr val="accent1"/>
+          </a:fillRef>
+          <a:effectRef idx="2">
+            <a:schemeClr val="accent1"/>
+          </a:effectRef>
+          <a:fontRef idx="minor">
+            <a:schemeClr val="lt1"/>
+          </a:fontRef>
+        </p:style>
+        <p:txBody>
+          <a:bodyPr rtlCol="0" anchor="ctr"/>
+          <a:lstStyle/>
+          <a:p>
+            <a:pPr algn="ctr"/>
+          </a:p>
+        </p:txBody>
+      </p:sp>
+      <p:sp>
+        <p:nvSpPr>
+          <p:cNvPr id="3" name="TextBox 2"/>
+          <p:cNvSpPr txBox="1"/>
+          <p:nvPr/>
+        </p:nvSpPr>
+        <p:spPr>
+          <a:xfrm>
+            <a:off x="502920" y="320040"/>
+            <a:ext cx="10972800" cy="274320"/>
+          </a:xfrm>
+          <a:prstGeom prst="rect">
+            <a:avLst/>
+          </a:prstGeom>
+          <a:noFill/>
+        </p:spPr>
+        <p:txBody>
+          <a:bodyPr wrap="square" lIns="0" rIns="0" tIns="0" bIns="0">
+            <a:noAutofit/>
+          </a:bodyPr>
+          <a:lstStyle/>
+          <a:p>
+            <a:pPr>
+              <a:spcAft>
+                <a:spcPts val="0"/>
+              </a:spcAft>
+              <a:defRPr sz="1100" b="1">
+                <a:solidFill>
+                  <a:srgbClr val="F38020"/>
+                </a:solidFill>
+                <a:latin typeface="DejaVu Sans"/>
+              </a:defRPr>
+            </a:pPr>
+            <a:r>
+              <a:t>OCTOBER 2026 UPDATE</a:t>
+            </a:r>
+          </a:p>
+        </p:txBody>
+      </p:sp>
+      <p:sp>
+        <p:nvSpPr>
+          <p:cNvPr id="4" name="TextBox 3"/>
+          <p:cNvSpPr txBox="1"/>
+          <p:nvPr/>
+        </p:nvSpPr>
+        <p:spPr>
+          <a:xfrm>
+            <a:off x="502920" y="795528"/>
+            <a:ext cx="11155680" cy="594360"/>
+          </a:xfrm>
+          <a:prstGeom prst="rect">
+            <a:avLst/>
+          </a:prstGeom>
+          <a:noFill/>
+        </p:spPr>
+        <p:txBody>
+          <a:bodyPr wrap="square" lIns="0" rIns="0" tIns="0" bIns="0">
+            <a:noAutofit/>
+          </a:bodyPr>
+          <a:lstStyle/>
+          <a:p>
+            <a:pPr>
+              <a:spcAft>
+                <a:spcPts val="0"/>
+              </a:spcAft>
+              <a:defRPr sz="3400" b="1">
+                <a:solidFill>
+                  <a:srgbClr val="0A2540"/>
+                </a:solidFill>
+                <a:latin typeface="DejaVu Sans"/>
+              </a:defRPr>
+            </a:pPr>
+            <a:r>
+              <a:t>Continuous monitoring deployment</a:t>
+            </a:r>
+          </a:p>
+        </p:txBody>
+      </p:sp>
+      <p:sp>
+        <p:nvSpPr>
+          <p:cNvPr id="5" name="TextBox 4"/>
+          <p:cNvSpPr txBox="1"/>
+          <p:nvPr/>
+        </p:nvSpPr>
+        <p:spPr>
+          <a:xfrm>
+            <a:off x="502920" y="1417320"/>
+            <a:ext cx="11155680" cy="768096"/>
+          </a:xfrm>
+          <a:prstGeom prst="rect">
+            <a:avLst/>
+          </a:prstGeom>
+          <a:noFill/>
+        </p:spPr>
+        <p:txBody>
+          <a:bodyPr wrap="square" lIns="0" rIns="0" tIns="0" bIns="0">
+            <a:noAutofit/>
+          </a:bodyPr>
+          <a:lstStyle/>
+          <a:p>
+            <a:pPr>
+              <a:lnSpc>
+                <a:spcPts val="2000"/>
+              </a:lnSpc>
+              <a:spcAft>
+                <a:spcPts val="0"/>
+              </a:spcAft>
+              <a:defRPr sz="1550" b="0">
+                <a:solidFill>
+                  <a:srgbClr val="334155"/>
+                </a:solidFill>
+                <a:latin typeface="DejaVu Sans"/>
+              </a:defRPr>
+            </a:pPr>
+            <a:r>
+              <a:t>The deployment adds a continuous monitoring dashboard, bounded host collectors, local source scanning and service templates. Health checks expose stale snapshots, while tenant-scoped access connects findings to operations. Deployment details and limits are documented in vulnsuite/README.md.</a:t>
+            </a:r>
+          </a:p>
+        </p:txBody>
+      </p:sp>
+      <p:sp>
+        <p:nvSpPr>
+          <p:cNvPr id="6" name="Rectangle 5"/>
+          <p:cNvSpPr/>
+          <p:nvPr/>
+        </p:nvSpPr>
+        <p:spPr>
+          <a:xfrm>
+            <a:off x="502920" y="2331720"/>
+            <a:ext cx="5404104" cy="3657600"/>
+          </a:xfrm>
+          <a:prstGeom prst="rect">
+            <a:avLst/>
+          </a:prstGeom>
+          <a:solidFill>
+            <a:srgbClr val="F3F6FA"/>
+          </a:solidFill>
+          <a:ln>
+            <a:noFill/>
+          </a:ln>
+        </p:spPr>
+        <p:style>
+          <a:lnRef idx="1">
+            <a:schemeClr val="accent1"/>
+          </a:lnRef>
+          <a:fillRef idx="3">
+            <a:schemeClr val="accent1"/>
+          </a:fillRef>
+          <a:effectRef idx="2">
+            <a:schemeClr val="accent1"/>
+          </a:effectRef>
+          <a:fontRef idx="minor">
+            <a:schemeClr val="lt1"/>
+          </a:fontRef>
+        </p:style>
+        <p:txBody>
+          <a:bodyPr rtlCol="0" anchor="ctr"/>
+          <a:lstStyle/>
+          <a:p>
+            <a:pPr algn="ctr"/>
+          </a:p>
+        </p:txBody>
+      </p:sp>
+      <p:sp>
+        <p:nvSpPr>
+          <p:cNvPr id="7" name="Rectangle 6"/>
+          <p:cNvSpPr/>
+          <p:nvPr/>
+        </p:nvSpPr>
+        <p:spPr>
+          <a:xfrm>
+            <a:off x="502920" y="2331720"/>
+            <a:ext cx="45720" cy="3657600"/>
+          </a:xfrm>
+          <a:prstGeom prst="rect">
+            <a:avLst/>
+          </a:prstGeom>
+          <a:solidFill>
+            <a:srgbClr val="F38020"/>
+          </a:solidFill>
+          <a:ln>
+            <a:noFill/>
+          </a:ln>
+        </p:spPr>
+        <p:style>
+          <a:lnRef idx="1">
+            <a:schemeClr val="accent1"/>
+          </a:lnRef>
+          <a:fillRef idx="3">
+            <a:schemeClr val="accent1"/>
+          </a:fillRef>
+          <a:effectRef idx="2">
+            <a:schemeClr val="accent1"/>
+          </a:effectRef>
+          <a:fontRef idx="minor">
+            <a:schemeClr val="lt1"/>
+          </a:fontRef>
+        </p:style>
+        <p:txBody>
+          <a:bodyPr rtlCol="0" anchor="ctr"/>
+          <a:lstStyle/>
+          <a:p>
+            <a:pPr algn="ctr"/>
+          </a:p>
+        </p:txBody>
+      </p:sp>
+      <p:sp>
+        <p:nvSpPr>
+          <p:cNvPr id="8" name="TextBox 7"/>
+          <p:cNvSpPr txBox="1"/>
+          <p:nvPr/>
+        </p:nvSpPr>
+        <p:spPr>
+          <a:xfrm>
+            <a:off x="749808" y="2542032"/>
+            <a:ext cx="4901184" cy="594360"/>
+          </a:xfrm>
+          <a:prstGeom prst="rect">
+            <a:avLst/>
+          </a:prstGeom>
+          <a:noFill/>
+        </p:spPr>
+        <p:txBody>
+          <a:bodyPr wrap="square" lIns="0" rIns="0" tIns="0" bIns="0">
+            <a:noAutofit/>
+          </a:bodyPr>
+          <a:lstStyle/>
+          <a:p>
+            <a:pPr>
+              <a:spcAft>
+                <a:spcPts val="0"/>
+              </a:spcAft>
+              <a:defRPr sz="2000" b="1">
+                <a:solidFill>
+                  <a:srgbClr val="0A2540"/>
+                </a:solidFill>
+                <a:latin typeface="DejaVu Sans"/>
+              </a:defRPr>
+            </a:pPr>
+            <a:r>
+              <a:t>Monitoring and findings</a:t>
+            </a:r>
+          </a:p>
+        </p:txBody>
+      </p:sp>
+      <p:sp>
+        <p:nvSpPr>
+          <p:cNvPr id="9" name="TextBox 8"/>
+          <p:cNvSpPr txBox="1"/>
+          <p:nvPr/>
+        </p:nvSpPr>
+        <p:spPr>
+          <a:xfrm>
+            <a:off x="749808" y="3236976"/>
+            <a:ext cx="4846320" cy="2615184"/>
+          </a:xfrm>
+          <a:prstGeom prst="rect">
+            <a:avLst/>
+          </a:prstGeom>
+          <a:noFill/>
+        </p:spPr>
+        <p:txBody>
+          <a:bodyPr wrap="square" lIns="0" rIns="0" tIns="0" bIns="0">
+            <a:noAutofit/>
+          </a:bodyPr>
+          <a:lstStyle/>
+          <a:p>
+            <a:pPr marL="182880" indent="-164592">
+              <a:lnSpc>
+                <a:spcPts val="2200"/>
+              </a:lnSpc>
+              <a:spcAft>
+                <a:spcPts val="800"/>
+              </a:spcAft>
+              <a:buChar char="•"/>
+              <a:defRPr sz="1700" b="0">
+                <a:solidFill>
+                  <a:srgbClr val="334155"/>
+                </a:solidFill>
+                <a:latin typeface="DejaVu Sans"/>
+              </a:defRPr>
+            </a:pPr>
+            <a:r>
+              <a:t>Minute-by-minute host snapshots</a:t>
+            </a:r>
+          </a:p>
+          <a:p>
+            <a:pPr marL="182880" indent="-164592">
+              <a:lnSpc>
+                <a:spcPts val="2200"/>
+              </a:lnSpc>
+              <a:spcAft>
+                <a:spcPts val="800"/>
+              </a:spcAft>
+              <a:buChar char="•"/>
+              <a:defRPr sz="1700">
+                <a:solidFill>
+                  <a:srgbClr val="334155"/>
+                </a:solidFill>
+                <a:latin typeface="DejaVu Sans"/>
+              </a:defRPr>
+            </a:pPr>
+            <a:r>
+              <a:t>Stale snapshot health checks</a:t>
+            </a:r>
+          </a:p>
+          <a:p>
+            <a:pPr marL="182880" indent="-164592">
+              <a:lnSpc>
+                <a:spcPts val="2200"/>
+              </a:lnSpc>
+              <a:spcAft>
+                <a:spcPts val="800"/>
+              </a:spcAft>
+              <a:buChar char="•"/>
+              <a:defRPr sz="1700">
+                <a:solidFill>
+                  <a:srgbClr val="334155"/>
+                </a:solidFill>
+                <a:latin typeface="DejaVu Sans"/>
+              </a:defRPr>
+            </a:pPr>
+            <a:r>
+              <a:t>Hourly scans of VulnSuite source</a:t>
+            </a:r>
+          </a:p>
+          <a:p>
+            <a:pPr marL="182880" indent="-164592">
+              <a:lnSpc>
+                <a:spcPts val="2200"/>
+              </a:lnSpc>
+              <a:spcAft>
+                <a:spcPts val="800"/>
+              </a:spcAft>
+              <a:buChar char="•"/>
+              <a:defRPr sz="1700">
+                <a:solidFill>
+                  <a:srgbClr val="334155"/>
+                </a:solidFill>
+                <a:latin typeface="DejaVu Sans"/>
+              </a:defRPr>
+            </a:pPr>
+            <a:r>
+              <a:t>Agent delivery health refresh</a:t>
+            </a:r>
+          </a:p>
+        </p:txBody>
+      </p:sp>
+      <p:sp>
+        <p:nvSpPr>
+          <p:cNvPr id="10" name="Rectangle 9"/>
+          <p:cNvSpPr/>
+          <p:nvPr/>
+        </p:nvSpPr>
+        <p:spPr>
+          <a:xfrm>
+            <a:off x="6281928" y="2331720"/>
+            <a:ext cx="5404104" cy="3657600"/>
+          </a:xfrm>
+          <a:prstGeom prst="rect">
+            <a:avLst/>
+          </a:prstGeom>
+          <a:solidFill>
+            <a:srgbClr val="F3F6FA"/>
+          </a:solidFill>
+          <a:ln>
+            <a:noFill/>
+          </a:ln>
+        </p:spPr>
+        <p:style>
+          <a:lnRef idx="1">
+            <a:schemeClr val="accent1"/>
+          </a:lnRef>
+          <a:fillRef idx="3">
+            <a:schemeClr val="accent1"/>
+          </a:fillRef>
+          <a:effectRef idx="2">
+            <a:schemeClr val="accent1"/>
+          </a:effectRef>
+          <a:fontRef idx="minor">
+            <a:schemeClr val="lt1"/>
+          </a:fontRef>
+        </p:style>
+        <p:txBody>
+          <a:bodyPr rtlCol="0" anchor="ctr"/>
+          <a:lstStyle/>
+          <a:p>
+            <a:pPr algn="ctr"/>
+          </a:p>
+        </p:txBody>
+      </p:sp>
+      <p:sp>
+        <p:nvSpPr>
+          <p:cNvPr id="11" name="Rectangle 10"/>
+          <p:cNvSpPr/>
+          <p:nvPr/>
+        </p:nvSpPr>
+        <p:spPr>
+          <a:xfrm>
+            <a:off x="6281928" y="2331720"/>
+            <a:ext cx="45720" cy="3657600"/>
+          </a:xfrm>
+          <a:prstGeom prst="rect">
+            <a:avLst/>
+          </a:prstGeom>
+          <a:solidFill>
+            <a:srgbClr val="F38020"/>
+          </a:solidFill>
+          <a:ln>
+            <a:noFill/>
+          </a:ln>
+        </p:spPr>
+        <p:style>
+          <a:lnRef idx="1">
+            <a:schemeClr val="accent1"/>
+          </a:lnRef>
+          <a:fillRef idx="3">
+            <a:schemeClr val="accent1"/>
+          </a:fillRef>
+          <a:effectRef idx="2">
+            <a:schemeClr val="accent1"/>
+          </a:effectRef>
+          <a:fontRef idx="minor">
+            <a:schemeClr val="lt1"/>
+          </a:fontRef>
+        </p:style>
+        <p:txBody>
+          <a:bodyPr rtlCol="0" anchor="ctr"/>
+          <a:lstStyle/>
+          <a:p>
+            <a:pPr algn="ctr"/>
+          </a:p>
+        </p:txBody>
+      </p:sp>
+      <p:sp>
+        <p:nvSpPr>
+          <p:cNvPr id="12" name="TextBox 11"/>
+          <p:cNvSpPr txBox="1"/>
+          <p:nvPr/>
+        </p:nvSpPr>
+        <p:spPr>
+          <a:xfrm>
+            <a:off x="6528816" y="2542032"/>
+            <a:ext cx="4901184" cy="594360"/>
+          </a:xfrm>
+          <a:prstGeom prst="rect">
+            <a:avLst/>
+          </a:prstGeom>
+          <a:noFill/>
+        </p:spPr>
+        <p:txBody>
+          <a:bodyPr wrap="square" lIns="0" rIns="0" tIns="0" bIns="0">
+            <a:noAutofit/>
+          </a:bodyPr>
+          <a:lstStyle/>
+          <a:p>
+            <a:pPr>
+              <a:spcAft>
+                <a:spcPts val="0"/>
+              </a:spcAft>
+              <a:defRPr sz="2000" b="1">
+                <a:solidFill>
+                  <a:srgbClr val="0A2540"/>
+                </a:solidFill>
+                <a:latin typeface="DejaVu Sans"/>
+              </a:defRPr>
+            </a:pPr>
+            <a:r>
+              <a:t>Deployment controls</a:t>
+            </a:r>
+          </a:p>
+        </p:txBody>
+      </p:sp>
+      <p:sp>
+        <p:nvSpPr>
+          <p:cNvPr id="13" name="TextBox 12"/>
+          <p:cNvSpPr txBox="1"/>
+          <p:nvPr/>
+        </p:nvSpPr>
+        <p:spPr>
+          <a:xfrm>
+            <a:off x="6528816" y="3236976"/>
+            <a:ext cx="4846320" cy="2615184"/>
+          </a:xfrm>
+          <a:prstGeom prst="rect">
+            <a:avLst/>
+          </a:prstGeom>
+          <a:noFill/>
+        </p:spPr>
+        <p:txBody>
+          <a:bodyPr wrap="square" lIns="0" rIns="0" tIns="0" bIns="0">
+            <a:noAutofit/>
+          </a:bodyPr>
+          <a:lstStyle/>
+          <a:p>
+            <a:pPr marL="182880" indent="-164592">
+              <a:lnSpc>
+                <a:spcPts val="2200"/>
+              </a:lnSpc>
+              <a:spcAft>
+                <a:spcPts val="800"/>
+              </a:spcAft>
+              <a:buChar char="•"/>
+              <a:defRPr sz="1700" b="0">
+                <a:solidFill>
+                  <a:srgbClr val="334155"/>
+                </a:solidFill>
+                <a:latin typeface="DejaVu Sans"/>
+              </a:defRPr>
+            </a:pPr>
+            <a:r>
+              <a:t>Dedicated PostgreSQL and Redis services</a:t>
+            </a:r>
+          </a:p>
+          <a:p>
+            <a:pPr marL="182880" indent="-164592">
+              <a:lnSpc>
+                <a:spcPts val="2200"/>
+              </a:lnSpc>
+              <a:spcAft>
+                <a:spcPts val="800"/>
+              </a:spcAft>
+              <a:buChar char="•"/>
+              <a:defRPr sz="1700">
+                <a:solidFill>
+                  <a:srgbClr val="334155"/>
+                </a:solidFill>
+                <a:latin typeface="DejaVu Sans"/>
+              </a:defRPr>
+            </a:pPr>
+            <a:r>
+              <a:t>Renewed tenant-scoped read tokens</a:t>
+            </a:r>
+          </a:p>
+          <a:p>
+            <a:pPr marL="182880" indent="-164592">
+              <a:lnSpc>
+                <a:spcPts val="2200"/>
+              </a:lnSpc>
+              <a:spcAft>
+                <a:spcPts val="800"/>
+              </a:spcAft>
+              <a:buChar char="•"/>
+              <a:defRPr sz="1700">
+                <a:solidFill>
+                  <a:srgbClr val="334155"/>
+                </a:solidFill>
+                <a:latin typeface="DejaVu Sans"/>
+              </a:defRPr>
+            </a:pPr>
+            <a:r>
+              <a:t>Systemd services and scheduled collectors</a:t>
+            </a:r>
+          </a:p>
+          <a:p>
+            <a:pPr marL="182880" indent="-164592">
+              <a:lnSpc>
+                <a:spcPts val="2200"/>
+              </a:lnSpc>
+              <a:spcAft>
+                <a:spcPts val="800"/>
+              </a:spcAft>
+              <a:buChar char="•"/>
+              <a:defRPr sz="1700">
+                <a:solidFill>
+                  <a:srgbClr val="334155"/>
+                </a:solidFill>
+                <a:latin typeface="DejaVu Sans"/>
+              </a:defRPr>
+            </a:pPr>
+            <a:r>
+              <a:t>Containment and external alerts disabled</a:t>
+            </a:r>
+          </a:p>
+        </p:txBody>
+      </p:sp>
+      <p:sp>
+        <p:nvSpPr>
+          <p:cNvPr id="14" name="TextBox 13"/>
+          <p:cNvSpPr txBox="1"/>
+          <p:nvPr/>
+        </p:nvSpPr>
+        <p:spPr>
+          <a:xfrm>
+            <a:off x="502920" y="6080760"/>
+            <a:ext cx="11155680" cy="384048"/>
+          </a:xfrm>
+          <a:prstGeom prst="rect">
+            <a:avLst/>
+          </a:prstGeom>
+          <a:noFill/>
+        </p:spPr>
+        <p:txBody>
+          <a:bodyPr wrap="square" lIns="0" rIns="0" tIns="0" bIns="0">
+            <a:noAutofit/>
+          </a:bodyPr>
+          <a:lstStyle/>
+          <a:p>
+            <a:pPr>
+              <a:spcAft>
+                <a:spcPts val="0"/>
+              </a:spcAft>
+              <a:defRPr sz="1100" b="0">
+                <a:solidFill>
+                  <a:srgbClr val="64748B"/>
+                </a:solidFill>
+                <a:latin typeface="DejaVu Sans"/>
+              </a:defRPr>
+            </a:pPr>
+            <a:r>
+              <a:t>Coverage depends on configured sources and targets; installed scanners do not imply active coverage.</a:t>
+            </a:r>
+          </a:p>
+        </p:txBody>
+      </p:sp>
+      <p:sp>
+        <p:nvSpPr>
+          <p:cNvPr id="15" name="TextBox 14"/>
+          <p:cNvSpPr txBox="1"/>
+          <p:nvPr/>
+        </p:nvSpPr>
+        <p:spPr>
+          <a:xfrm>
+            <a:off x="502920" y="6519672"/>
+            <a:ext cx="10058400" cy="182880"/>
+          </a:xfrm>
+          <a:prstGeom prst="rect">
+            <a:avLst/>
+          </a:prstGeom>
+          <a:noFill/>
+        </p:spPr>
+        <p:txBody>
+          <a:bodyPr wrap="square" lIns="0" rIns="0" tIns="0" bIns="0">
+            <a:noAutofit/>
+          </a:bodyPr>
+          <a:lstStyle/>
+          <a:p>
+            <a:pPr>
+              <a:spcAft>
+                <a:spcPts val="0"/>
+              </a:spcAft>
+              <a:defRPr sz="900" b="0">
+                <a:solidFill>
+                  <a:srgbClr val="64748B"/>
+                </a:solidFill>
+                <a:latin typeface="DejaVu Sans"/>
+              </a:defRPr>
+            </a:pPr>
+            <a:r>
+              <a:t>CONFIDENTIAL • INTERNAL REVIEW  |  21 October 2026</a:t>
+            </a:r>
+          </a:p>
+        </p:txBody>
+      </p:sp>
+      <p:sp>
+        <p:nvSpPr>
+          <p:cNvPr id="16" name="TextBox 15"/>
+          <p:cNvSpPr txBox="1"/>
+          <p:nvPr/>
+        </p:nvSpPr>
+        <p:spPr>
+          <a:xfrm>
+            <a:off x="11045952" y="6519672"/>
+            <a:ext cx="685800" cy="182880"/>
+          </a:xfrm>
+          <a:prstGeom prst="rect">
+            <a:avLst/>
+          </a:prstGeom>
+          <a:noFill/>
+        </p:spPr>
+        <p:txBody>
+          <a:bodyPr wrap="square" lIns="0" rIns="0" tIns="0" bIns="0">
+            <a:noAutofit/>
+          </a:bodyPr>
+          <a:lstStyle/>
+          <a:p>
+            <a:pPr>
+              <a:spcAft>
+                <a:spcPts val="0"/>
+              </a:spcAft>
+              <a:defRPr sz="900" b="0">
+                <a:solidFill>
+                  <a:srgbClr val="64748B"/>
+                </a:solidFill>
+                <a:latin typeface="DejaVu Sans"/>
+              </a:defRPr>
+            </a:pPr>
+            <a:r>
+              <a:t>20 / 20</a:t>
             </a:r>
           </a:p>
         </p:txBody>
@@ -14826,7 +15671,7 @@
               </a:defRPr>
             </a:pPr>
             <a:r>
-              <a:t>CONFIDENTIAL • INTERNAL REVIEW  |  19 October 2026</a:t>
+              <a:t>CONFIDENTIAL • INTERNAL REVIEW  |  21 October 2026</a:t>
             </a:r>
           </a:p>
         </p:txBody>
@@ -14865,7 +15710,7 @@
               </a:defRPr>
             </a:pPr>
             <a:r>
-              <a:t>03 / 19</a:t>
+              <a:t>03 / 20</a:t>
             </a:r>
           </a:p>
         </p:txBody>
@@ -15560,7 +16405,7 @@
               </a:defRPr>
             </a:pPr>
             <a:r>
-              <a:t>CONFIDENTIAL • INTERNAL REVIEW  |  19 October 2026</a:t>
+              <a:t>CONFIDENTIAL • INTERNAL REVIEW  |  21 October 2026</a:t>
             </a:r>
           </a:p>
         </p:txBody>
@@ -15599,7 +16444,7 @@
               </a:defRPr>
             </a:pPr>
             <a:r>
-              <a:t>04 / 19</a:t>
+              <a:t>04 / 20</a:t>
             </a:r>
           </a:p>
         </p:txBody>
@@ -16274,7 +17119,7 @@
               </a:defRPr>
             </a:pPr>
             <a:r>
-              <a:t>CONFIDENTIAL • INTERNAL REVIEW  |  19 October 2026</a:t>
+              <a:t>CONFIDENTIAL • INTERNAL REVIEW  |  21 October 2026</a:t>
             </a:r>
           </a:p>
         </p:txBody>
@@ -16313,7 +17158,7 @@
               </a:defRPr>
             </a:pPr>
             <a:r>
-              <a:t>05 / 19</a:t>
+              <a:t>05 / 20</a:t>
             </a:r>
           </a:p>
         </p:txBody>
@@ -17028,7 +17873,7 @@
               </a:defRPr>
             </a:pPr>
             <a:r>
-              <a:t>CONFIDENTIAL • INTERNAL REVIEW  |  19 October 2026</a:t>
+              <a:t>CONFIDENTIAL • INTERNAL REVIEW  |  21 October 2026</a:t>
             </a:r>
           </a:p>
         </p:txBody>
@@ -17067,7 +17912,7 @@
               </a:defRPr>
             </a:pPr>
             <a:r>
-              <a:t>06 / 19</a:t>
+              <a:t>06 / 20</a:t>
             </a:r>
           </a:p>
         </p:txBody>
@@ -17782,7 +18627,7 @@
               </a:defRPr>
             </a:pPr>
             <a:r>
-              <a:t>CONFIDENTIAL • INTERNAL REVIEW  |  19 October 2026</a:t>
+              <a:t>CONFIDENTIAL • INTERNAL REVIEW  |  21 October 2026</a:t>
             </a:r>
           </a:p>
         </p:txBody>
@@ -17821,7 +18666,7 @@
               </a:defRPr>
             </a:pPr>
             <a:r>
-              <a:t>07 / 19</a:t>
+              <a:t>07 / 20</a:t>
             </a:r>
           </a:p>
         </p:txBody>
@@ -18536,7 +19381,7 @@
               </a:defRPr>
             </a:pPr>
             <a:r>
-              <a:t>CONFIDENTIAL • INTERNAL REVIEW  |  19 October 2026</a:t>
+              <a:t>CONFIDENTIAL • INTERNAL REVIEW  |  21 October 2026</a:t>
             </a:r>
           </a:p>
         </p:txBody>
@@ -18575,7 +19420,7 @@
               </a:defRPr>
             </a:pPr>
             <a:r>
-              <a:t>08 / 19</a:t>
+              <a:t>08 / 20</a:t>
             </a:r>
           </a:p>
         </p:txBody>
@@ -19290,7 +20135,7 @@
               </a:defRPr>
             </a:pPr>
             <a:r>
-              <a:t>CONFIDENTIAL • INTERNAL REVIEW  |  19 October 2026</a:t>
+              <a:t>CONFIDENTIAL • INTERNAL REVIEW  |  21 October 2026</a:t>
             </a:r>
           </a:p>
         </p:txBody>
@@ -19329,7 +20174,7 @@
               </a:defRPr>
             </a:pPr>
             <a:r>
-              <a:t>09 / 19</a:t>
+              <a:t>09 / 20</a:t>
             </a:r>
           </a:p>
         </p:txBody>

</xml_diff>